<commit_message>
refactor: update pitch deck content and positioning for professional firms
- Revised the pitch deck to emphasize AKILI as a governance intelligence platform for affluent families and the professional firms that serve them, rather than solely for wealth advisors.
- Updated key messaging across multiple slides to reflect a unified approach to family governance, highlighting the collaborative role of various professionals (CPAs, estate attorneys, etc.) in managing family risk.
- Enhanced descriptions of the product's features and benefits to align with the new positioning, ensuring clarity on the platform's value proposition for both families and professional firms.
- Adjusted the business model and market segmentation to better represent the diverse professional audience and their specific needs.
- Made corresponding updates to related documentation and outreach templates to maintain consistency in messaging.
</commit_message>
<xml_diff>
--- a/docs/pitch-decks/Akili-Investor-Deck.pptx
+++ b/docs/pitch-decks/Akili-Investor-Deck.pptx
@@ -2490,7 +2490,7 @@
                 <a:ea typeface="Calibri" pitchFamily="34" charset="-122"/>
                 <a:cs typeface="Calibri" pitchFamily="34" charset="-120"/>
               </a:rPr>
-              <a:t>SaaS — advisor and firm subscriptions</a:t>
+              <a:t>SaaS — firm and practice subscriptions</a:t>
             </a:r>
             <a:endParaRPr lang="en-US" sz="1400" dirty="0"/>
           </a:p>
@@ -2835,7 +2835,7 @@
                           <a:ea typeface="Calibri" pitchFamily="34" charset="-122"/>
                           <a:cs typeface="Calibri" pitchFamily="34" charset="-120"/>
                         </a:rPr>
-                        <a:t>Starter</a:t>
+                        <a:t>Essentials</a:t>
                       </a:r>
                       <a:endParaRPr lang="en-US" sz="1000" dirty="0">
                         <a:latin typeface="Calibri" charset="0"/>
@@ -2971,7 +2971,7 @@
                           <a:ea typeface="Calibri" pitchFamily="34" charset="-122"/>
                           <a:cs typeface="Calibri" pitchFamily="34" charset="-120"/>
                         </a:rPr>
-                        <a:t>Solo advisor</a:t>
+                        <a:t>Solo practitioner</a:t>
                       </a:r>
                       <a:endParaRPr lang="en-US" sz="1000" dirty="0">
                         <a:latin typeface="Calibri" charset="0"/>
@@ -3041,7 +3041,7 @@
                           <a:ea typeface="Calibri" pitchFamily="34" charset="-122"/>
                           <a:cs typeface="Calibri" pitchFamily="34" charset="-120"/>
                         </a:rPr>
-                        <a:t>Growth</a:t>
+                        <a:t>Professional</a:t>
                       </a:r>
                       <a:endParaRPr lang="en-US" sz="1000" dirty="0">
                         <a:latin typeface="Calibri" charset="0"/>
@@ -3177,7 +3177,7 @@
                           <a:ea typeface="Calibri" pitchFamily="34" charset="-122"/>
                           <a:cs typeface="Calibri" pitchFamily="34" charset="-120"/>
                         </a:rPr>
-                        <a:t>Small practice</a:t>
+                        <a:t>Established firm + customization</a:t>
                       </a:r>
                       <a:endParaRPr lang="en-US" sz="1000" dirty="0">
                         <a:latin typeface="Calibri" charset="0"/>
@@ -3247,7 +3247,7 @@
                           <a:ea typeface="Calibri" pitchFamily="34" charset="-122"/>
                           <a:cs typeface="Calibri" pitchFamily="34" charset="-120"/>
                         </a:rPr>
-                        <a:t>Professional</a:t>
+                        <a:t>Business</a:t>
                       </a:r>
                       <a:endParaRPr lang="en-US" sz="1000" dirty="0">
                         <a:latin typeface="Calibri" charset="0"/>
@@ -3383,7 +3383,7 @@
                           <a:ea typeface="Calibri" pitchFamily="34" charset="-122"/>
                           <a:cs typeface="Calibri" pitchFamily="34" charset="-120"/>
                         </a:rPr>
-                        <a:t>Established firm + branding</a:t>
+                        <a:t>Growing firm + branding</a:t>
                       </a:r>
                       <a:endParaRPr lang="en-US" sz="1000" dirty="0">
                         <a:latin typeface="Calibri" charset="0"/>
@@ -3431,6 +3431,212 @@
                     </a:lnB>
                     <a:solidFill>
                       <a:srgbClr val="F8FAFC"/>
+                    </a:solidFill>
+                  </a:tcPr>
+                </a:tc>
+              </a:tr>
+              <a:tr h="0">
+                <a:tc>
+                  <a:txBody>
+                    <a:bodyPr/>
+                    <a:lstStyle/>
+                    <a:p>
+                      <a:pPr indent="0" marL="0">
+                        <a:buNone/>
+                      </a:pPr>
+                      <a:r>
+                        <a:rPr lang="en-US" sz="1000" dirty="0">
+                          <a:solidFill>
+                            <a:srgbClr val="1E293B"/>
+                          </a:solidFill>
+                          <a:latin typeface="Calibri" pitchFamily="34" charset="0"/>
+                          <a:ea typeface="Calibri" pitchFamily="34" charset="-122"/>
+                          <a:cs typeface="Calibri" pitchFamily="34" charset="-120"/>
+                        </a:rPr>
+                        <a:t>Platinum</a:t>
+                      </a:r>
+                      <a:endParaRPr lang="en-US" sz="1000" dirty="0">
+                        <a:latin typeface="Calibri" charset="0"/>
+                        <a:ea typeface="Calibri" charset="0"/>
+                        <a:cs typeface="Calibri" charset="0"/>
+                      </a:endParaRPr>
+                    </a:p>
+                  </a:txBody>
+                  <a:tcPr marL="91440" marR="91440" marT="45720" marB="45720" anchor="t">
+                    <a:lnL w="6350" cap="flat" cmpd="sng" algn="ctr">
+                      <a:solidFill>
+                        <a:srgbClr val="E2E8F0"/>
+                      </a:solidFill>
+                      <a:prstDash val="solid"/>
+                      <a:round/>
+                      <a:headEnd type="none" w="med" len="med"/>
+                      <a:tailEnd type="none" w="med" len="med"/>
+                    </a:lnL>
+                    <a:lnR w="6350" cap="flat" cmpd="sng" algn="ctr">
+                      <a:solidFill>
+                        <a:srgbClr val="E2E8F0"/>
+                      </a:solidFill>
+                      <a:prstDash val="solid"/>
+                      <a:round/>
+                      <a:headEnd type="none" w="med" len="med"/>
+                      <a:tailEnd type="none" w="med" len="med"/>
+                    </a:lnR>
+                    <a:lnT w="6350" cap="flat" cmpd="sng" algn="ctr">
+                      <a:solidFill>
+                        <a:srgbClr val="E2E8F0"/>
+                      </a:solidFill>
+                      <a:prstDash val="solid"/>
+                      <a:round/>
+                      <a:headEnd type="none" w="med" len="med"/>
+                      <a:tailEnd type="none" w="med" len="med"/>
+                    </a:lnT>
+                    <a:lnB w="6350" cap="flat" cmpd="sng" algn="ctr">
+                      <a:solidFill>
+                        <a:srgbClr val="E2E8F0"/>
+                      </a:solidFill>
+                      <a:prstDash val="solid"/>
+                      <a:round/>
+                      <a:headEnd type="none" w="med" len="med"/>
+                      <a:tailEnd type="none" w="med" len="med"/>
+                    </a:lnB>
+                    <a:solidFill>
+                      <a:srgbClr val="FFFFFF"/>
+                    </a:solidFill>
+                  </a:tcPr>
+                </a:tc>
+                <a:tc>
+                  <a:txBody>
+                    <a:bodyPr/>
+                    <a:lstStyle/>
+                    <a:p>
+                      <a:pPr indent="0" marL="0">
+                        <a:buNone/>
+                      </a:pPr>
+                      <a:r>
+                        <a:rPr lang="en-US" sz="1000" dirty="0">
+                          <a:solidFill>
+                            <a:srgbClr val="1E293B"/>
+                          </a:solidFill>
+                          <a:latin typeface="Calibri" pitchFamily="34" charset="0"/>
+                          <a:ea typeface="Calibri" pitchFamily="34" charset="-122"/>
+                          <a:cs typeface="Calibri" pitchFamily="34" charset="-120"/>
+                        </a:rPr>
+                        <a:t>250</a:t>
+                      </a:r>
+                      <a:endParaRPr lang="en-US" sz="1000" dirty="0">
+                        <a:latin typeface="Calibri" charset="0"/>
+                        <a:ea typeface="Calibri" charset="0"/>
+                        <a:cs typeface="Calibri" charset="0"/>
+                      </a:endParaRPr>
+                    </a:p>
+                  </a:txBody>
+                  <a:tcPr marL="91440" marR="91440" marT="45720" marB="45720" anchor="t">
+                    <a:lnL w="6350" cap="flat" cmpd="sng" algn="ctr">
+                      <a:solidFill>
+                        <a:srgbClr val="E2E8F0"/>
+                      </a:solidFill>
+                      <a:prstDash val="solid"/>
+                      <a:round/>
+                      <a:headEnd type="none" w="med" len="med"/>
+                      <a:tailEnd type="none" w="med" len="med"/>
+                    </a:lnL>
+                    <a:lnR w="6350" cap="flat" cmpd="sng" algn="ctr">
+                      <a:solidFill>
+                        <a:srgbClr val="E2E8F0"/>
+                      </a:solidFill>
+                      <a:prstDash val="solid"/>
+                      <a:round/>
+                      <a:headEnd type="none" w="med" len="med"/>
+                      <a:tailEnd type="none" w="med" len="med"/>
+                    </a:lnR>
+                    <a:lnT w="6350" cap="flat" cmpd="sng" algn="ctr">
+                      <a:solidFill>
+                        <a:srgbClr val="E2E8F0"/>
+                      </a:solidFill>
+                      <a:prstDash val="solid"/>
+                      <a:round/>
+                      <a:headEnd type="none" w="med" len="med"/>
+                      <a:tailEnd type="none" w="med" len="med"/>
+                    </a:lnT>
+                    <a:lnB w="6350" cap="flat" cmpd="sng" algn="ctr">
+                      <a:solidFill>
+                        <a:srgbClr val="E2E8F0"/>
+                      </a:solidFill>
+                      <a:prstDash val="solid"/>
+                      <a:round/>
+                      <a:headEnd type="none" w="med" len="med"/>
+                      <a:tailEnd type="none" w="med" len="med"/>
+                    </a:lnB>
+                    <a:solidFill>
+                      <a:srgbClr val="FFFFFF"/>
+                    </a:solidFill>
+                  </a:tcPr>
+                </a:tc>
+                <a:tc>
+                  <a:txBody>
+                    <a:bodyPr/>
+                    <a:lstStyle/>
+                    <a:p>
+                      <a:pPr indent="0" marL="0">
+                        <a:buNone/>
+                      </a:pPr>
+                      <a:r>
+                        <a:rPr lang="en-US" sz="1000" dirty="0">
+                          <a:solidFill>
+                            <a:srgbClr val="1E293B"/>
+                          </a:solidFill>
+                          <a:latin typeface="Calibri" pitchFamily="34" charset="0"/>
+                          <a:ea typeface="Calibri" pitchFamily="34" charset="-122"/>
+                          <a:cs typeface="Calibri" pitchFamily="34" charset="-120"/>
+                        </a:rPr>
+                        <a:t>High-volume firm</a:t>
+                      </a:r>
+                      <a:endParaRPr lang="en-US" sz="1000" dirty="0">
+                        <a:latin typeface="Calibri" charset="0"/>
+                        <a:ea typeface="Calibri" charset="0"/>
+                        <a:cs typeface="Calibri" charset="0"/>
+                      </a:endParaRPr>
+                    </a:p>
+                  </a:txBody>
+                  <a:tcPr marL="91440" marR="91440" marT="45720" marB="45720" anchor="t">
+                    <a:lnL w="6350" cap="flat" cmpd="sng" algn="ctr">
+                      <a:solidFill>
+                        <a:srgbClr val="E2E8F0"/>
+                      </a:solidFill>
+                      <a:prstDash val="solid"/>
+                      <a:round/>
+                      <a:headEnd type="none" w="med" len="med"/>
+                      <a:tailEnd type="none" w="med" len="med"/>
+                    </a:lnL>
+                    <a:lnR w="6350" cap="flat" cmpd="sng" algn="ctr">
+                      <a:solidFill>
+                        <a:srgbClr val="E2E8F0"/>
+                      </a:solidFill>
+                      <a:prstDash val="solid"/>
+                      <a:round/>
+                      <a:headEnd type="none" w="med" len="med"/>
+                      <a:tailEnd type="none" w="med" len="med"/>
+                    </a:lnR>
+                    <a:lnT w="6350" cap="flat" cmpd="sng" algn="ctr">
+                      <a:solidFill>
+                        <a:srgbClr val="E2E8F0"/>
+                      </a:solidFill>
+                      <a:prstDash val="solid"/>
+                      <a:round/>
+                      <a:headEnd type="none" w="med" len="med"/>
+                      <a:tailEnd type="none" w="med" len="med"/>
+                    </a:lnT>
+                    <a:lnB w="6350" cap="flat" cmpd="sng" algn="ctr">
+                      <a:solidFill>
+                        <a:srgbClr val="E2E8F0"/>
+                      </a:solidFill>
+                      <a:prstDash val="solid"/>
+                      <a:round/>
+                      <a:headEnd type="none" w="med" len="med"/>
+                      <a:tailEnd type="none" w="med" len="med"/>
+                    </a:lnB>
+                    <a:solidFill>
+                      <a:srgbClr val="FFFFFF"/>
                     </a:solidFill>
                   </a:tcPr>
                 </a:tc>
@@ -3500,7 +3706,7 @@
                       <a:tailEnd type="none" w="med" len="med"/>
                     </a:lnB>
                     <a:solidFill>
-                      <a:srgbClr val="FFFFFF"/>
+                      <a:srgbClr val="F8FAFC"/>
                     </a:solidFill>
                   </a:tcPr>
                 </a:tc>
@@ -3568,7 +3774,7 @@
                       <a:tailEnd type="none" w="med" len="med"/>
                     </a:lnB>
                     <a:solidFill>
-                      <a:srgbClr val="FFFFFF"/>
+                      <a:srgbClr val="F8FAFC"/>
                     </a:solidFill>
                   </a:tcPr>
                 </a:tc>
@@ -3589,7 +3795,7 @@
                           <a:ea typeface="Calibri" pitchFamily="34" charset="-122"/>
                           <a:cs typeface="Calibri" pitchFamily="34" charset="-120"/>
                         </a:rPr>
-                        <a:t>Multi-advisor firms (sales-assisted)</a:t>
+                        <a:t>Multi-seat firms (sales-assisted)</a:t>
                       </a:r>
                       <a:endParaRPr lang="en-US" sz="1000" dirty="0">
                         <a:latin typeface="Calibri" charset="0"/>
@@ -3636,7 +3842,7 @@
                       <a:tailEnd type="none" w="med" len="med"/>
                     </a:lnB>
                     <a:solidFill>
-                      <a:srgbClr val="FFFFFF"/>
+                      <a:srgbClr val="F8FAFC"/>
                     </a:solidFill>
                   </a:tcPr>
                 </a:tc>
@@ -4226,7 +4432,7 @@
                           <a:ea typeface="Calibri" pitchFamily="34" charset="-122"/>
                           <a:cs typeface="Calibri" pitchFamily="34" charset="-120"/>
                         </a:rPr>
-                        <a:t>Portfolio &amp; assets</a:t>
+                        <a:t>Siloed expertise (tax, legal, wealth)</a:t>
                       </a:r>
                       <a:endParaRPr lang="en-US" sz="1000" dirty="0">
                         <a:latin typeface="Calibri" charset="0"/>
@@ -4294,7 +4500,7 @@
                           <a:ea typeface="Calibri" pitchFamily="34" charset="-122"/>
                           <a:cs typeface="Calibri" pitchFamily="34" charset="-120"/>
                         </a:rPr>
-                        <a:t>Whole-family risk</a:t>
+                        <a:t>Whole-family operational risk</a:t>
                       </a:r>
                       <a:endParaRPr lang="en-US" sz="1000" dirty="0">
                         <a:latin typeface="Calibri" charset="0"/>
@@ -4844,7 +5050,7 @@
                           <a:ea typeface="Calibri" pitchFamily="34" charset="-122"/>
                           <a:cs typeface="Calibri" pitchFamily="34" charset="-120"/>
                         </a:rPr>
-                        <a:t>Financial</a:t>
+                        <a:t>Single-domain</a:t>
                       </a:r>
                       <a:endParaRPr lang="en-US" sz="1000" dirty="0">
                         <a:latin typeface="Calibri" charset="0"/>
@@ -4912,7 +5118,7 @@
                           <a:ea typeface="Calibri" pitchFamily="34" charset="-122"/>
                           <a:cs typeface="Calibri" pitchFamily="34" charset="-120"/>
                         </a:rPr>
-                        <a:t>Governance + cyber + estate + 7 more</a:t>
+                        <a:t>Governance + cyber + estate + tax + 7 more</a:t>
                       </a:r>
                       <a:endParaRPr lang="en-US" sz="1000" dirty="0">
                         <a:latin typeface="Calibri" charset="0"/>
@@ -4960,6 +5166,212 @@
                     </a:lnB>
                     <a:solidFill>
                       <a:srgbClr val="FFFFFF"/>
+                    </a:solidFill>
+                  </a:tcPr>
+                </a:tc>
+              </a:tr>
+              <a:tr h="0">
+                <a:tc>
+                  <a:txBody>
+                    <a:bodyPr/>
+                    <a:lstStyle/>
+                    <a:p>
+                      <a:pPr indent="0" marL="0">
+                        <a:buNone/>
+                      </a:pPr>
+                      <a:r>
+                        <a:rPr lang="en-US" sz="1000" dirty="0">
+                          <a:solidFill>
+                            <a:srgbClr val="1E293B"/>
+                          </a:solidFill>
+                          <a:latin typeface="Calibri" pitchFamily="34" charset="0"/>
+                          <a:ea typeface="Calibri" pitchFamily="34" charset="-122"/>
+                          <a:cs typeface="Calibri" pitchFamily="34" charset="-120"/>
+                        </a:rPr>
+                        <a:t>Delivery</a:t>
+                      </a:r>
+                      <a:endParaRPr lang="en-US" sz="1000" dirty="0">
+                        <a:latin typeface="Calibri" charset="0"/>
+                        <a:ea typeface="Calibri" charset="0"/>
+                        <a:cs typeface="Calibri" charset="0"/>
+                      </a:endParaRPr>
+                    </a:p>
+                  </a:txBody>
+                  <a:tcPr marL="91440" marR="91440" marT="45720" marB="45720" anchor="t">
+                    <a:lnL w="6350" cap="flat" cmpd="sng" algn="ctr">
+                      <a:solidFill>
+                        <a:srgbClr val="E2E8F0"/>
+                      </a:solidFill>
+                      <a:prstDash val="solid"/>
+                      <a:round/>
+                      <a:headEnd type="none" w="med" len="med"/>
+                      <a:tailEnd type="none" w="med" len="med"/>
+                    </a:lnL>
+                    <a:lnR w="6350" cap="flat" cmpd="sng" algn="ctr">
+                      <a:solidFill>
+                        <a:srgbClr val="E2E8F0"/>
+                      </a:solidFill>
+                      <a:prstDash val="solid"/>
+                      <a:round/>
+                      <a:headEnd type="none" w="med" len="med"/>
+                      <a:tailEnd type="none" w="med" len="med"/>
+                    </a:lnR>
+                    <a:lnT w="6350" cap="flat" cmpd="sng" algn="ctr">
+                      <a:solidFill>
+                        <a:srgbClr val="E2E8F0"/>
+                      </a:solidFill>
+                      <a:prstDash val="solid"/>
+                      <a:round/>
+                      <a:headEnd type="none" w="med" len="med"/>
+                      <a:tailEnd type="none" w="med" len="med"/>
+                    </a:lnT>
+                    <a:lnB w="6350" cap="flat" cmpd="sng" algn="ctr">
+                      <a:solidFill>
+                        <a:srgbClr val="E2E8F0"/>
+                      </a:solidFill>
+                      <a:prstDash val="solid"/>
+                      <a:round/>
+                      <a:headEnd type="none" w="med" len="med"/>
+                      <a:tailEnd type="none" w="med" len="med"/>
+                    </a:lnB>
+                    <a:solidFill>
+                      <a:srgbClr val="F8FAFC"/>
+                    </a:solidFill>
+                  </a:tcPr>
+                </a:tc>
+                <a:tc>
+                  <a:txBody>
+                    <a:bodyPr/>
+                    <a:lstStyle/>
+                    <a:p>
+                      <a:pPr indent="0" marL="0">
+                        <a:buNone/>
+                      </a:pPr>
+                      <a:r>
+                        <a:rPr lang="en-US" sz="1000" dirty="0">
+                          <a:solidFill>
+                            <a:srgbClr val="1E293B"/>
+                          </a:solidFill>
+                          <a:latin typeface="Calibri" pitchFamily="34" charset="0"/>
+                          <a:ea typeface="Calibri" pitchFamily="34" charset="-122"/>
+                          <a:cs typeface="Calibri" pitchFamily="34" charset="-120"/>
+                        </a:rPr>
+                        <a:t>Generic vendor branding</a:t>
+                      </a:r>
+                      <a:endParaRPr lang="en-US" sz="1000" dirty="0">
+                        <a:latin typeface="Calibri" charset="0"/>
+                        <a:ea typeface="Calibri" charset="0"/>
+                        <a:cs typeface="Calibri" charset="0"/>
+                      </a:endParaRPr>
+                    </a:p>
+                  </a:txBody>
+                  <a:tcPr marL="91440" marR="91440" marT="45720" marB="45720" anchor="t">
+                    <a:lnL w="6350" cap="flat" cmpd="sng" algn="ctr">
+                      <a:solidFill>
+                        <a:srgbClr val="E2E8F0"/>
+                      </a:solidFill>
+                      <a:prstDash val="solid"/>
+                      <a:round/>
+                      <a:headEnd type="none" w="med" len="med"/>
+                      <a:tailEnd type="none" w="med" len="med"/>
+                    </a:lnL>
+                    <a:lnR w="6350" cap="flat" cmpd="sng" algn="ctr">
+                      <a:solidFill>
+                        <a:srgbClr val="E2E8F0"/>
+                      </a:solidFill>
+                      <a:prstDash val="solid"/>
+                      <a:round/>
+                      <a:headEnd type="none" w="med" len="med"/>
+                      <a:tailEnd type="none" w="med" len="med"/>
+                    </a:lnR>
+                    <a:lnT w="6350" cap="flat" cmpd="sng" algn="ctr">
+                      <a:solidFill>
+                        <a:srgbClr val="E2E8F0"/>
+                      </a:solidFill>
+                      <a:prstDash val="solid"/>
+                      <a:round/>
+                      <a:headEnd type="none" w="med" len="med"/>
+                      <a:tailEnd type="none" w="med" len="med"/>
+                    </a:lnT>
+                    <a:lnB w="6350" cap="flat" cmpd="sng" algn="ctr">
+                      <a:solidFill>
+                        <a:srgbClr val="E2E8F0"/>
+                      </a:solidFill>
+                      <a:prstDash val="solid"/>
+                      <a:round/>
+                      <a:headEnd type="none" w="med" len="med"/>
+                      <a:tailEnd type="none" w="med" len="med"/>
+                    </a:lnB>
+                    <a:solidFill>
+                      <a:srgbClr val="F8FAFC"/>
+                    </a:solidFill>
+                  </a:tcPr>
+                </a:tc>
+                <a:tc>
+                  <a:txBody>
+                    <a:bodyPr/>
+                    <a:lstStyle/>
+                    <a:p>
+                      <a:pPr indent="0" marL="0">
+                        <a:buNone/>
+                      </a:pPr>
+                      <a:r>
+                        <a:rPr lang="en-US" sz="1000" dirty="0">
+                          <a:solidFill>
+                            <a:srgbClr val="1E293B"/>
+                          </a:solidFill>
+                          <a:latin typeface="Calibri" pitchFamily="34" charset="0"/>
+                          <a:ea typeface="Calibri" pitchFamily="34" charset="-122"/>
+                          <a:cs typeface="Calibri" pitchFamily="34" charset="-120"/>
+                        </a:rPr>
+                        <a:t>White-label subdomain, custom intake, firm methodology</a:t>
+                      </a:r>
+                      <a:endParaRPr lang="en-US" sz="1000" dirty="0">
+                        <a:latin typeface="Calibri" charset="0"/>
+                        <a:ea typeface="Calibri" charset="0"/>
+                        <a:cs typeface="Calibri" charset="0"/>
+                      </a:endParaRPr>
+                    </a:p>
+                  </a:txBody>
+                  <a:tcPr marL="91440" marR="91440" marT="45720" marB="45720" anchor="t">
+                    <a:lnL w="6350" cap="flat" cmpd="sng" algn="ctr">
+                      <a:solidFill>
+                        <a:srgbClr val="E2E8F0"/>
+                      </a:solidFill>
+                      <a:prstDash val="solid"/>
+                      <a:round/>
+                      <a:headEnd type="none" w="med" len="med"/>
+                      <a:tailEnd type="none" w="med" len="med"/>
+                    </a:lnL>
+                    <a:lnR w="6350" cap="flat" cmpd="sng" algn="ctr">
+                      <a:solidFill>
+                        <a:srgbClr val="E2E8F0"/>
+                      </a:solidFill>
+                      <a:prstDash val="solid"/>
+                      <a:round/>
+                      <a:headEnd type="none" w="med" len="med"/>
+                      <a:tailEnd type="none" w="med" len="med"/>
+                    </a:lnR>
+                    <a:lnT w="6350" cap="flat" cmpd="sng" algn="ctr">
+                      <a:solidFill>
+                        <a:srgbClr val="E2E8F0"/>
+                      </a:solidFill>
+                      <a:prstDash val="solid"/>
+                      <a:round/>
+                      <a:headEnd type="none" w="med" len="med"/>
+                      <a:tailEnd type="none" w="med" len="med"/>
+                    </a:lnT>
+                    <a:lnB w="6350" cap="flat" cmpd="sng" algn="ctr">
+                      <a:solidFill>
+                        <a:srgbClr val="E2E8F0"/>
+                      </a:solidFill>
+                      <a:prstDash val="solid"/>
+                      <a:round/>
+                      <a:headEnd type="none" w="med" len="med"/>
+                      <a:tailEnd type="none" w="med" len="med"/>
+                    </a:lnB>
+                    <a:solidFill>
+                      <a:srgbClr val="F8FAFC"/>
                     </a:solidFill>
                   </a:tcPr>
                 </a:tc>
@@ -5029,7 +5441,7 @@
                       <a:tailEnd type="none" w="med" len="med"/>
                     </a:lnB>
                     <a:solidFill>
-                      <a:srgbClr val="F8FAFC"/>
+                      <a:srgbClr val="FFFFFF"/>
                     </a:solidFill>
                   </a:tcPr>
                 </a:tc>
@@ -5097,7 +5509,7 @@
                       <a:tailEnd type="none" w="med" len="med"/>
                     </a:lnB>
                     <a:solidFill>
-                      <a:srgbClr val="F8FAFC"/>
+                      <a:srgbClr val="FFFFFF"/>
                     </a:solidFill>
                   </a:tcPr>
                 </a:tc>
@@ -5165,7 +5577,7 @@
                       <a:tailEnd type="none" w="med" len="med"/>
                     </a:lnB>
                     <a:solidFill>
-                      <a:srgbClr val="F8FAFC"/>
+                      <a:srgbClr val="FFFFFF"/>
                     </a:solidFill>
                   </a:tcPr>
                 </a:tc>
@@ -5246,7 +5658,7 @@
                 <a:ea typeface="Calibri" pitchFamily="34" charset="-122"/>
                 <a:cs typeface="Calibri" pitchFamily="34" charset="-120"/>
               </a:rPr>
-              <a:t>The system of record for family governance — the platform that compounds with every engagement.</a:t>
+              <a:t>The system of record for family governance — plus white-label delivery so firms own the client relationship.</a:t>
             </a:r>
             <a:endParaRPr lang="en-US" sz="1300" dirty="0"/>
           </a:p>
@@ -5943,7 +6355,7 @@
                           <a:ea typeface="Calibri" pitchFamily="34" charset="-122"/>
                           <a:cs typeface="Calibri" pitchFamily="34" charset="-120"/>
                         </a:rPr>
-                        <a:t>Platform bank, advisor-customizable</a:t>
+                        <a:t>Platform bank, firm-customizable</a:t>
                       </a:r>
                       <a:endParaRPr lang="en-US" sz="1000" dirty="0">
                         <a:latin typeface="Calibri" charset="0"/>
@@ -6013,7 +6425,7 @@
                           <a:ea typeface="Calibri" pitchFamily="34" charset="-122"/>
                           <a:cs typeface="Calibri" pitchFamily="34" charset="-120"/>
                         </a:rPr>
-                        <a:t>Advisor portal</a:t>
+                        <a:t>Practitioner workspace</a:t>
                       </a:r>
                       <a:endParaRPr lang="en-US" sz="1000" dirty="0">
                         <a:latin typeface="Calibri" charset="0"/>
@@ -6219,7 +6631,7 @@
                           <a:ea typeface="Calibri" pitchFamily="34" charset="-122"/>
                           <a:cs typeface="Calibri" pitchFamily="34" charset="-120"/>
                         </a:rPr>
-                        <a:t>Multi-seat, branded subdomains, Stripe billing</a:t>
+                        <a:t>Subdomains, custom intake, methodology overlays, Stripe billing</a:t>
                       </a:r>
                       <a:endParaRPr lang="en-US" sz="1000" dirty="0">
                         <a:latin typeface="Calibri" charset="0"/>
@@ -6267,6 +6679,144 @@
                     </a:lnB>
                     <a:solidFill>
                       <a:srgbClr val="FFFFFF"/>
+                    </a:solidFill>
+                  </a:tcPr>
+                </a:tc>
+              </a:tr>
+              <a:tr h="0">
+                <a:tc>
+                  <a:txBody>
+                    <a:bodyPr/>
+                    <a:lstStyle/>
+                    <a:p>
+                      <a:pPr indent="0" marL="0">
+                        <a:buNone/>
+                      </a:pPr>
+                      <a:r>
+                        <a:rPr lang="en-US" sz="1000" dirty="0">
+                          <a:solidFill>
+                            <a:srgbClr val="1E293B"/>
+                          </a:solidFill>
+                          <a:latin typeface="Calibri" pitchFamily="34" charset="0"/>
+                          <a:ea typeface="Calibri" pitchFamily="34" charset="-122"/>
+                          <a:cs typeface="Calibri" pitchFamily="34" charset="-120"/>
+                        </a:rPr>
+                        <a:t>Full lifecycle</a:t>
+                      </a:r>
+                      <a:endParaRPr lang="en-US" sz="1000" dirty="0">
+                        <a:latin typeface="Calibri" charset="0"/>
+                        <a:ea typeface="Calibri" charset="0"/>
+                        <a:cs typeface="Calibri" charset="0"/>
+                      </a:endParaRPr>
+                    </a:p>
+                  </a:txBody>
+                  <a:tcPr marL="91440" marR="91440" marT="45720" marB="45720" anchor="t">
+                    <a:lnL w="6350" cap="flat" cmpd="sng" algn="ctr">
+                      <a:solidFill>
+                        <a:srgbClr val="E2E8F0"/>
+                      </a:solidFill>
+                      <a:prstDash val="solid"/>
+                      <a:round/>
+                      <a:headEnd type="none" w="med" len="med"/>
+                      <a:tailEnd type="none" w="med" len="med"/>
+                    </a:lnL>
+                    <a:lnR w="6350" cap="flat" cmpd="sng" algn="ctr">
+                      <a:solidFill>
+                        <a:srgbClr val="E2E8F0"/>
+                      </a:solidFill>
+                      <a:prstDash val="solid"/>
+                      <a:round/>
+                      <a:headEnd type="none" w="med" len="med"/>
+                      <a:tailEnd type="none" w="med" len="med"/>
+                    </a:lnR>
+                    <a:lnT w="6350" cap="flat" cmpd="sng" algn="ctr">
+                      <a:solidFill>
+                        <a:srgbClr val="E2E8F0"/>
+                      </a:solidFill>
+                      <a:prstDash val="solid"/>
+                      <a:round/>
+                      <a:headEnd type="none" w="med" len="med"/>
+                      <a:tailEnd type="none" w="med" len="med"/>
+                    </a:lnT>
+                    <a:lnB w="6350" cap="flat" cmpd="sng" algn="ctr">
+                      <a:solidFill>
+                        <a:srgbClr val="E2E8F0"/>
+                      </a:solidFill>
+                      <a:prstDash val="solid"/>
+                      <a:round/>
+                      <a:headEnd type="none" w="med" len="med"/>
+                      <a:tailEnd type="none" w="med" len="med"/>
+                    </a:lnB>
+                    <a:solidFill>
+                      <a:srgbClr val="F8FAFC"/>
+                    </a:solidFill>
+                  </a:tcPr>
+                </a:tc>
+                <a:tc>
+                  <a:txBody>
+                    <a:bodyPr/>
+                    <a:lstStyle/>
+                    <a:p>
+                      <a:pPr indent="0" marL="0">
+                        <a:buNone/>
+                      </a:pPr>
+                      <a:r>
+                        <a:rPr lang="en-US" sz="1000" dirty="0">
+                          <a:solidFill>
+                            <a:srgbClr val="1E293B"/>
+                          </a:solidFill>
+                          <a:latin typeface="Calibri" pitchFamily="34" charset="0"/>
+                          <a:ea typeface="Calibri" pitchFamily="34" charset="-122"/>
+                          <a:cs typeface="Calibri" pitchFamily="34" charset="-120"/>
+                        </a:rPr>
+                        <a:t>Action plans · tracking · reassessment</a:t>
+                      </a:r>
+                      <a:endParaRPr lang="en-US" sz="1000" dirty="0">
+                        <a:latin typeface="Calibri" charset="0"/>
+                        <a:ea typeface="Calibri" charset="0"/>
+                        <a:cs typeface="Calibri" charset="0"/>
+                      </a:endParaRPr>
+                    </a:p>
+                  </a:txBody>
+                  <a:tcPr marL="91440" marR="91440" marT="45720" marB="45720" anchor="t">
+                    <a:lnL w="6350" cap="flat" cmpd="sng" algn="ctr">
+                      <a:solidFill>
+                        <a:srgbClr val="E2E8F0"/>
+                      </a:solidFill>
+                      <a:prstDash val="solid"/>
+                      <a:round/>
+                      <a:headEnd type="none" w="med" len="med"/>
+                      <a:tailEnd type="none" w="med" len="med"/>
+                    </a:lnL>
+                    <a:lnR w="6350" cap="flat" cmpd="sng" algn="ctr">
+                      <a:solidFill>
+                        <a:srgbClr val="E2E8F0"/>
+                      </a:solidFill>
+                      <a:prstDash val="solid"/>
+                      <a:round/>
+                      <a:headEnd type="none" w="med" len="med"/>
+                      <a:tailEnd type="none" w="med" len="med"/>
+                    </a:lnR>
+                    <a:lnT w="6350" cap="flat" cmpd="sng" algn="ctr">
+                      <a:solidFill>
+                        <a:srgbClr val="E2E8F0"/>
+                      </a:solidFill>
+                      <a:prstDash val="solid"/>
+                      <a:round/>
+                      <a:headEnd type="none" w="med" len="med"/>
+                      <a:tailEnd type="none" w="med" len="med"/>
+                    </a:lnT>
+                    <a:lnB w="6350" cap="flat" cmpd="sng" algn="ctr">
+                      <a:solidFill>
+                        <a:srgbClr val="E2E8F0"/>
+                      </a:solidFill>
+                      <a:prstDash val="solid"/>
+                      <a:round/>
+                      <a:headEnd type="none" w="med" len="med"/>
+                      <a:tailEnd type="none" w="med" len="med"/>
+                    </a:lnB>
+                    <a:solidFill>
+                      <a:srgbClr val="F8FAFC"/>
                     </a:solidFill>
                   </a:tcPr>
                 </a:tc>
@@ -6336,7 +6886,7 @@
                       <a:tailEnd type="none" w="med" len="med"/>
                     </a:lnB>
                     <a:solidFill>
-                      <a:srgbClr val="F8FAFC"/>
+                      <a:srgbClr val="FFFFFF"/>
                     </a:solidFill>
                   </a:tcPr>
                 </a:tc>
@@ -6404,7 +6954,7 @@
                       <a:tailEnd type="none" w="med" len="med"/>
                     </a:lnB>
                     <a:solidFill>
-                      <a:srgbClr val="F8FAFC"/>
+                      <a:srgbClr val="FFFFFF"/>
                     </a:solidFill>
                   </a:tcPr>
                 </a:tc>
@@ -6911,7 +7461,7 @@
                           <a:ea typeface="Calibri" pitchFamily="34" charset="-122"/>
                           <a:cs typeface="Calibri" pitchFamily="34" charset="-120"/>
                         </a:rPr>
-                        <a:t>10-pillar assessment, advisor workflow, white-label, enterprise, billing</a:t>
+                        <a:t>10-pillar assessment, professional workflow, lifecycle loop, enterprise, billing</a:t>
                       </a:r>
                       <a:endParaRPr lang="en-US" sz="1000" dirty="0">
                         <a:latin typeface="Calibri" charset="0"/>
@@ -7049,7 +7599,7 @@
                           <a:ea typeface="Calibri" pitchFamily="34" charset="-122"/>
                           <a:cs typeface="Calibri" pitchFamily="34" charset="-120"/>
                         </a:rPr>
-                        <a:t>Cross-pillar AI insights · action plans · continuity scoring</a:t>
+                        <a:t>Cross-pillar AI insights · executive reporting · continuity scoring</a:t>
                       </a:r>
                       <a:endParaRPr lang="en-US" sz="1000" dirty="0">
                         <a:latin typeface="Calibri" charset="0"/>
@@ -7675,7 +8225,7 @@
                 <a:ea typeface="Calibri" pitchFamily="34" charset="-122"/>
                 <a:cs typeface="Calibri" pitchFamily="34" charset="-120"/>
               </a:rPr>
-              <a:t>Built alongside practitioners — real advisor and family-office workflows</a:t>
+              <a:t>Built alongside practitioners — wealth, tax, legal, and family-office workflows</a:t>
             </a:r>
             <a:endParaRPr lang="en-US" sz="1500" dirty="0"/>
           </a:p>
@@ -7894,7 +8444,7 @@
                 <a:ea typeface="Calibri" pitchFamily="34" charset="-122"/>
                 <a:cs typeface="Calibri" pitchFamily="34" charset="-120"/>
               </a:rPr>
-              <a:t>We're raising $[X]M to become the governance intelligence platform powering the next generation of wealth advisory.</a:t>
+              <a:t>We're raising $3.5M Seed to become the governance intelligence platform for modern family wealth.</a:t>
             </a:r>
             <a:endParaRPr lang="en-US" sz="1600" dirty="0"/>
           </a:p>
@@ -8128,7 +8678,7 @@
                           <a:ea typeface="Calibri" pitchFamily="34" charset="-122"/>
                           <a:cs typeface="Calibri" pitchFamily="34" charset="-120"/>
                         </a:rPr>
-                        <a:t>$[X]M Seed / Pre-Seed</a:t>
+                        <a:t>$3.5M Seed</a:t>
                       </a:r>
                       <a:endParaRPr lang="en-US" sz="1000" dirty="0">
                         <a:latin typeface="Calibri" charset="0"/>
@@ -8928,7 +9478,7 @@
                 <a:ea typeface="Calibri Light" pitchFamily="34" charset="-122"/>
                 <a:cs typeface="Calibri Light" pitchFamily="34" charset="-120"/>
               </a:rPr>
-              <a:t>Financial planning manages assets.</a:t>
+              <a:t>Every professional protects a piece of the family.</a:t>
             </a:r>
             <a:endParaRPr lang="en-US" sz="2600" dirty="0"/>
           </a:p>
@@ -8945,7 +9495,7 @@
                 <a:ea typeface="Calibri Light" pitchFamily="34" charset="-122"/>
                 <a:cs typeface="Calibri Light" pitchFamily="34" charset="-120"/>
               </a:rPr>
-              <a:t>Nobody manages family risk.</a:t>
+              <a:t>Nobody owns the whole picture.</a:t>
             </a:r>
             <a:endParaRPr lang="en-US" sz="2600" dirty="0"/>
           </a:p>
@@ -8984,7 +9534,7 @@
                 <a:ea typeface="Calibri" pitchFamily="34" charset="-122"/>
                 <a:cs typeface="Calibri" pitchFamily="34" charset="-120"/>
               </a:rPr>
-              <a:t>Families spend millions protecting their wealth — advisors, insurance, estate counsel, cybersecurity — but almost nothing measuring the operational risks that actually destroy it.</a:t>
+              <a:t>Families spend millions on wealth management, tax planning, estate counsel, and cybersecurity — but almost nothing measuring whether the family itself is governable over time.</a:t>
             </a:r>
             <a:endParaRPr lang="en-US" sz="1600" dirty="0"/>
           </a:p>
@@ -9380,7 +9930,7 @@
                 <a:ea typeface="Calibri" pitchFamily="34" charset="-122"/>
                 <a:cs typeface="Calibri" pitchFamily="34" charset="-120"/>
               </a:rPr>
-              <a:t>The financial advisor wasn't included</a:t>
+              <a:t>The wealth advisor, CPA, and estate attorney each had a fragment — none had the whole picture</a:t>
             </a:r>
             <a:endParaRPr lang="en-US" sz="1500" dirty="0"/>
           </a:p>
@@ -10230,7 +10780,7 @@
                           <a:ea typeface="Calibri" pitchFamily="34" charset="-122"/>
                           <a:cs typeface="Calibri" pitchFamily="34" charset="-120"/>
                         </a:rPr>
-                        <a:t>Advisor commoditization</a:t>
+                        <a:t>Professional commoditization</a:t>
                       </a:r>
                       <a:endParaRPr lang="en-US" sz="1000" dirty="0">
                         <a:latin typeface="Calibri" charset="0"/>
@@ -10298,7 +10848,7 @@
                           <a:ea typeface="Calibri" pitchFamily="34" charset="-122"/>
                           <a:cs typeface="Calibri" pitchFamily="34" charset="-120"/>
                         </a:rPr>
-                        <a:t>Differentiation beyond portfolio returns</a:t>
+                        <a:t>Differentiation beyond siloed expertise</a:t>
                       </a:r>
                       <a:endParaRPr lang="en-US" sz="1000" dirty="0">
                         <a:latin typeface="Calibri" charset="0"/>
@@ -10663,7 +11213,7 @@
                 <a:ea typeface="Calibri" pitchFamily="34" charset="-122"/>
                 <a:cs typeface="Calibri" pitchFamily="34" charset="-120"/>
               </a:rPr>
-              <a:t>The window is open for a new category between financial planning and family continuity.</a:t>
+              <a:t>The window is open for a new category between fragmented professional advice and family continuity.</a:t>
             </a:r>
             <a:endParaRPr lang="en-US" sz="1200" dirty="0"/>
           </a:p>
@@ -11559,7 +12109,7 @@
                           <a:ea typeface="Calibri" pitchFamily="34" charset="-122"/>
                           <a:cs typeface="Calibri" pitchFamily="34" charset="-120"/>
                         </a:rPr>
-                        <a:t>Portfolio-wide patterns across an advisor's client book</a:t>
+                        <a:t>Portfolio-wide patterns across a firm's client book</a:t>
                       </a:r>
                       <a:endParaRPr lang="en-US" sz="1000" dirty="0">
                         <a:latin typeface="Calibri" charset="0"/>
@@ -11697,7 +12247,7 @@
                           <a:ea typeface="Calibri" pitchFamily="34" charset="-122"/>
                           <a:cs typeface="Calibri" pitchFamily="34" charset="-120"/>
                         </a:rPr>
-                        <a:t>Advisors, families, and deliverables in one workflow</a:t>
+                        <a:t>Professionals, families, and deliverables in one workflow</a:t>
                       </a:r>
                       <a:endParaRPr lang="en-US" sz="1000" dirty="0">
                         <a:latin typeface="Calibri" charset="0"/>
@@ -15416,7 +15966,7 @@
                 <a:ea typeface="Calibri" pitchFamily="34" charset="-122"/>
                 <a:cs typeface="Calibri" pitchFamily="34" charset="-120"/>
               </a:rPr>
-              <a:t>Advisors scope 1–10 pillars per engagement.</a:t>
+              <a:t>Firms scope 1–10 pillars per engagement.</a:t>
             </a:r>
             <a:endParaRPr lang="en-US" sz="1200" dirty="0"/>
           </a:p>
@@ -15576,7 +16126,7 @@
                 <a:ea typeface="Calibri" pitchFamily="34" charset="-122"/>
                 <a:cs typeface="Calibri" pitchFamily="34" charset="-120"/>
               </a:rPr>
-              <a:t>Beachhead: wealth advisors &amp; RIAs serving HNW households</a:t>
+              <a:t>One platform · multiple professional front doors · wealth advisory deployed first</a:t>
             </a:r>
             <a:endParaRPr lang="en-US" sz="1400" dirty="0"/>
           </a:p>
@@ -15920,7 +16470,7 @@
                           <a:ea typeface="Calibri" pitchFamily="34" charset="-122"/>
                           <a:cs typeface="Calibri" pitchFamily="34" charset="-120"/>
                         </a:rPr>
-                        <a:t>$[X]B global — advisor digitization</a:t>
+                        <a:t>$[X]B global — professional digitization</a:t>
                       </a:r>
                       <a:endParaRPr lang="en-US" sz="1000" dirty="0">
                         <a:latin typeface="Calibri" charset="0"/>
@@ -16128,7 +16678,7 @@
                           <a:ea typeface="Calibri" pitchFamily="34" charset="-122"/>
                           <a:cs typeface="Calibri" pitchFamily="34" charset="-120"/>
                         </a:rPr>
-                        <a:t>RIA-managed assets</a:t>
+                        <a:t>HNW professional services</a:t>
                       </a:r>
                       <a:endParaRPr lang="en-US" sz="1000" dirty="0">
                         <a:latin typeface="Calibri" charset="0"/>
@@ -16196,7 +16746,7 @@
                           <a:ea typeface="Calibri" pitchFamily="34" charset="-122"/>
                           <a:cs typeface="Calibri" pitchFamily="34" charset="-120"/>
                         </a:rPr>
-                        <a:t>$[X]T+ under advisory</a:t>
+                        <a:t>$[X]B+ advisory, tax, legal, succession</a:t>
                       </a:r>
                       <a:endParaRPr lang="en-US" sz="1000" dirty="0">
                         <a:latin typeface="Calibri" charset="0"/>
@@ -16572,7 +17122,7 @@
                           <a:ea typeface="Calibri" pitchFamily="34" charset="-122"/>
                           <a:cs typeface="Calibri" pitchFamily="34" charset="-120"/>
                         </a:rPr>
-                        <a:t>~300K+ financial advisors (US)</a:t>
+                        <a:t>Wealth advisors &amp; RIAs (US)</a:t>
                       </a:r>
                       <a:endParaRPr lang="en-US" sz="1000" dirty="0">
                         <a:latin typeface="Calibri" charset="0"/>
@@ -16640,7 +17190,7 @@
                           <a:ea typeface="Calibri" pitchFamily="34" charset="-122"/>
                           <a:cs typeface="Calibri" pitchFamily="34" charset="-120"/>
                         </a:rPr>
-                        <a:t>Differentiation beyond AUM</a:t>
+                        <a:t>Governance beyond portfolio returns</a:t>
                       </a:r>
                       <a:endParaRPr lang="en-US" sz="1000" dirty="0">
                         <a:latin typeface="Calibri" charset="0"/>
@@ -16710,7 +17260,283 @@
                           <a:ea typeface="Calibri" pitchFamily="34" charset="-122"/>
                           <a:cs typeface="Calibri" pitchFamily="34" charset="-120"/>
                         </a:rPr>
-                        <a:t>~10K+ family offices (global)</a:t>
+                        <a:t>CPAs &amp; tax advisory firms</a:t>
+                      </a:r>
+                      <a:endParaRPr lang="en-US" sz="1000" dirty="0">
+                        <a:latin typeface="Calibri" charset="0"/>
+                        <a:ea typeface="Calibri" charset="0"/>
+                        <a:cs typeface="Calibri" charset="0"/>
+                      </a:endParaRPr>
+                    </a:p>
+                  </a:txBody>
+                  <a:tcPr marL="91440" marR="91440" marT="45720" marB="45720" anchor="t">
+                    <a:lnL w="6350" cap="flat" cmpd="sng" algn="ctr">
+                      <a:solidFill>
+                        <a:srgbClr val="E2E8F0"/>
+                      </a:solidFill>
+                      <a:prstDash val="solid"/>
+                      <a:round/>
+                      <a:headEnd type="none" w="med" len="med"/>
+                      <a:tailEnd type="none" w="med" len="med"/>
+                    </a:lnL>
+                    <a:lnR w="6350" cap="flat" cmpd="sng" algn="ctr">
+                      <a:solidFill>
+                        <a:srgbClr val="E2E8F0"/>
+                      </a:solidFill>
+                      <a:prstDash val="solid"/>
+                      <a:round/>
+                      <a:headEnd type="none" w="med" len="med"/>
+                      <a:tailEnd type="none" w="med" len="med"/>
+                    </a:lnR>
+                    <a:lnT w="6350" cap="flat" cmpd="sng" algn="ctr">
+                      <a:solidFill>
+                        <a:srgbClr val="E2E8F0"/>
+                      </a:solidFill>
+                      <a:prstDash val="solid"/>
+                      <a:round/>
+                      <a:headEnd type="none" w="med" len="med"/>
+                      <a:tailEnd type="none" w="med" len="med"/>
+                    </a:lnT>
+                    <a:lnB w="6350" cap="flat" cmpd="sng" algn="ctr">
+                      <a:solidFill>
+                        <a:srgbClr val="E2E8F0"/>
+                      </a:solidFill>
+                      <a:prstDash val="solid"/>
+                      <a:round/>
+                      <a:headEnd type="none" w="med" len="med"/>
+                      <a:tailEnd type="none" w="med" len="med"/>
+                    </a:lnB>
+                    <a:solidFill>
+                      <a:srgbClr val="FFFFFF"/>
+                    </a:solidFill>
+                  </a:tcPr>
+                </a:tc>
+                <a:tc>
+                  <a:txBody>
+                    <a:bodyPr/>
+                    <a:lstStyle/>
+                    <a:p>
+                      <a:pPr indent="0" marL="0">
+                        <a:buNone/>
+                      </a:pPr>
+                      <a:r>
+                        <a:rPr lang="en-US" sz="1000" dirty="0">
+                          <a:solidFill>
+                            <a:srgbClr val="1E293B"/>
+                          </a:solidFill>
+                          <a:latin typeface="Calibri" pitchFamily="34" charset="0"/>
+                          <a:ea typeface="Calibri" pitchFamily="34" charset="-122"/>
+                          <a:cs typeface="Calibri" pitchFamily="34" charset="-120"/>
+                        </a:rPr>
+                        <a:t>Tax, liquidity, continuity intelligence</a:t>
+                      </a:r>
+                      <a:endParaRPr lang="en-US" sz="1000" dirty="0">
+                        <a:latin typeface="Calibri" charset="0"/>
+                        <a:ea typeface="Calibri" charset="0"/>
+                        <a:cs typeface="Calibri" charset="0"/>
+                      </a:endParaRPr>
+                    </a:p>
+                  </a:txBody>
+                  <a:tcPr marL="91440" marR="91440" marT="45720" marB="45720" anchor="t">
+                    <a:lnL w="6350" cap="flat" cmpd="sng" algn="ctr">
+                      <a:solidFill>
+                        <a:srgbClr val="E2E8F0"/>
+                      </a:solidFill>
+                      <a:prstDash val="solid"/>
+                      <a:round/>
+                      <a:headEnd type="none" w="med" len="med"/>
+                      <a:tailEnd type="none" w="med" len="med"/>
+                    </a:lnL>
+                    <a:lnR w="6350" cap="flat" cmpd="sng" algn="ctr">
+                      <a:solidFill>
+                        <a:srgbClr val="E2E8F0"/>
+                      </a:solidFill>
+                      <a:prstDash val="solid"/>
+                      <a:round/>
+                      <a:headEnd type="none" w="med" len="med"/>
+                      <a:tailEnd type="none" w="med" len="med"/>
+                    </a:lnR>
+                    <a:lnT w="6350" cap="flat" cmpd="sng" algn="ctr">
+                      <a:solidFill>
+                        <a:srgbClr val="E2E8F0"/>
+                      </a:solidFill>
+                      <a:prstDash val="solid"/>
+                      <a:round/>
+                      <a:headEnd type="none" w="med" len="med"/>
+                      <a:tailEnd type="none" w="med" len="med"/>
+                    </a:lnT>
+                    <a:lnB w="6350" cap="flat" cmpd="sng" algn="ctr">
+                      <a:solidFill>
+                        <a:srgbClr val="E2E8F0"/>
+                      </a:solidFill>
+                      <a:prstDash val="solid"/>
+                      <a:round/>
+                      <a:headEnd type="none" w="med" len="med"/>
+                      <a:tailEnd type="none" w="med" len="med"/>
+                    </a:lnB>
+                    <a:solidFill>
+                      <a:srgbClr val="FFFFFF"/>
+                    </a:solidFill>
+                  </a:tcPr>
+                </a:tc>
+              </a:tr>
+              <a:tr h="0">
+                <a:tc>
+                  <a:txBody>
+                    <a:bodyPr/>
+                    <a:lstStyle/>
+                    <a:p>
+                      <a:pPr indent="0" marL="0">
+                        <a:buNone/>
+                      </a:pPr>
+                      <a:r>
+                        <a:rPr lang="en-US" sz="1000" dirty="0">
+                          <a:solidFill>
+                            <a:srgbClr val="1E293B"/>
+                          </a:solidFill>
+                          <a:latin typeface="Calibri" pitchFamily="34" charset="0"/>
+                          <a:ea typeface="Calibri" pitchFamily="34" charset="-122"/>
+                          <a:cs typeface="Calibri" pitchFamily="34" charset="-120"/>
+                        </a:rPr>
+                        <a:t>Estate attorneys &amp; succession planners</a:t>
+                      </a:r>
+                      <a:endParaRPr lang="en-US" sz="1000" dirty="0">
+                        <a:latin typeface="Calibri" charset="0"/>
+                        <a:ea typeface="Calibri" charset="0"/>
+                        <a:cs typeface="Calibri" charset="0"/>
+                      </a:endParaRPr>
+                    </a:p>
+                  </a:txBody>
+                  <a:tcPr marL="91440" marR="91440" marT="45720" marB="45720" anchor="t">
+                    <a:lnL w="6350" cap="flat" cmpd="sng" algn="ctr">
+                      <a:solidFill>
+                        <a:srgbClr val="E2E8F0"/>
+                      </a:solidFill>
+                      <a:prstDash val="solid"/>
+                      <a:round/>
+                      <a:headEnd type="none" w="med" len="med"/>
+                      <a:tailEnd type="none" w="med" len="med"/>
+                    </a:lnL>
+                    <a:lnR w="6350" cap="flat" cmpd="sng" algn="ctr">
+                      <a:solidFill>
+                        <a:srgbClr val="E2E8F0"/>
+                      </a:solidFill>
+                      <a:prstDash val="solid"/>
+                      <a:round/>
+                      <a:headEnd type="none" w="med" len="med"/>
+                      <a:tailEnd type="none" w="med" len="med"/>
+                    </a:lnR>
+                    <a:lnT w="6350" cap="flat" cmpd="sng" algn="ctr">
+                      <a:solidFill>
+                        <a:srgbClr val="E2E8F0"/>
+                      </a:solidFill>
+                      <a:prstDash val="solid"/>
+                      <a:round/>
+                      <a:headEnd type="none" w="med" len="med"/>
+                      <a:tailEnd type="none" w="med" len="med"/>
+                    </a:lnT>
+                    <a:lnB w="6350" cap="flat" cmpd="sng" algn="ctr">
+                      <a:solidFill>
+                        <a:srgbClr val="E2E8F0"/>
+                      </a:solidFill>
+                      <a:prstDash val="solid"/>
+                      <a:round/>
+                      <a:headEnd type="none" w="med" len="med"/>
+                      <a:tailEnd type="none" w="med" len="med"/>
+                    </a:lnB>
+                    <a:solidFill>
+                      <a:srgbClr val="F8FAFC"/>
+                    </a:solidFill>
+                  </a:tcPr>
+                </a:tc>
+                <a:tc>
+                  <a:txBody>
+                    <a:bodyPr/>
+                    <a:lstStyle/>
+                    <a:p>
+                      <a:pPr indent="0" marL="0">
+                        <a:buNone/>
+                      </a:pPr>
+                      <a:r>
+                        <a:rPr lang="en-US" sz="1000" dirty="0">
+                          <a:solidFill>
+                            <a:srgbClr val="1E293B"/>
+                          </a:solidFill>
+                          <a:latin typeface="Calibri" pitchFamily="34" charset="0"/>
+                          <a:ea typeface="Calibri" pitchFamily="34" charset="-122"/>
+                          <a:cs typeface="Calibri" pitchFamily="34" charset="-120"/>
+                        </a:rPr>
+                        <a:t>Evidence-based governance assessment</a:t>
+                      </a:r>
+                      <a:endParaRPr lang="en-US" sz="1000" dirty="0">
+                        <a:latin typeface="Calibri" charset="0"/>
+                        <a:ea typeface="Calibri" charset="0"/>
+                        <a:cs typeface="Calibri" charset="0"/>
+                      </a:endParaRPr>
+                    </a:p>
+                  </a:txBody>
+                  <a:tcPr marL="91440" marR="91440" marT="45720" marB="45720" anchor="t">
+                    <a:lnL w="6350" cap="flat" cmpd="sng" algn="ctr">
+                      <a:solidFill>
+                        <a:srgbClr val="E2E8F0"/>
+                      </a:solidFill>
+                      <a:prstDash val="solid"/>
+                      <a:round/>
+                      <a:headEnd type="none" w="med" len="med"/>
+                      <a:tailEnd type="none" w="med" len="med"/>
+                    </a:lnL>
+                    <a:lnR w="6350" cap="flat" cmpd="sng" algn="ctr">
+                      <a:solidFill>
+                        <a:srgbClr val="E2E8F0"/>
+                      </a:solidFill>
+                      <a:prstDash val="solid"/>
+                      <a:round/>
+                      <a:headEnd type="none" w="med" len="med"/>
+                      <a:tailEnd type="none" w="med" len="med"/>
+                    </a:lnR>
+                    <a:lnT w="6350" cap="flat" cmpd="sng" algn="ctr">
+                      <a:solidFill>
+                        <a:srgbClr val="E2E8F0"/>
+                      </a:solidFill>
+                      <a:prstDash val="solid"/>
+                      <a:round/>
+                      <a:headEnd type="none" w="med" len="med"/>
+                      <a:tailEnd type="none" w="med" len="med"/>
+                    </a:lnT>
+                    <a:lnB w="6350" cap="flat" cmpd="sng" algn="ctr">
+                      <a:solidFill>
+                        <a:srgbClr val="E2E8F0"/>
+                      </a:solidFill>
+                      <a:prstDash val="solid"/>
+                      <a:round/>
+                      <a:headEnd type="none" w="med" len="med"/>
+                      <a:tailEnd type="none" w="med" len="med"/>
+                    </a:lnB>
+                    <a:solidFill>
+                      <a:srgbClr val="F8FAFC"/>
+                    </a:solidFill>
+                  </a:tcPr>
+                </a:tc>
+              </a:tr>
+              <a:tr h="0">
+                <a:tc>
+                  <a:txBody>
+                    <a:bodyPr/>
+                    <a:lstStyle/>
+                    <a:p>
+                      <a:pPr indent="0" marL="0">
+                        <a:buNone/>
+                      </a:pPr>
+                      <a:r>
+                        <a:rPr lang="en-US" sz="1000" dirty="0">
+                          <a:solidFill>
+                            <a:srgbClr val="1E293B"/>
+                          </a:solidFill>
+                          <a:latin typeface="Calibri" pitchFamily="34" charset="0"/>
+                          <a:ea typeface="Calibri" pitchFamily="34" charset="-122"/>
+                          <a:cs typeface="Calibri" pitchFamily="34" charset="-120"/>
+                        </a:rPr>
+                        <a:t>Family offices (global)</a:t>
                       </a:r>
                       <a:endParaRPr lang="en-US" sz="1000" dirty="0">
                         <a:latin typeface="Calibri" charset="0"/>
@@ -16848,7 +17674,7 @@
                           <a:ea typeface="Calibri" pitchFamily="34" charset="-122"/>
                           <a:cs typeface="Calibri" pitchFamily="34" charset="-120"/>
                         </a:rPr>
-                        <a:t>Enterprise advisory firms</a:t>
+                        <a:t>Enterprise professional firms</a:t>
                       </a:r>
                       <a:endParaRPr lang="en-US" sz="1000" dirty="0">
                         <a:latin typeface="Calibri" charset="0"/>

</xml_diff>